<commit_message>
Add presentation prep briefings for Vidhi, Arnau and Rachel; fix deck section references
- New Word + Markdown briefings in easy language for Receiving (Vidhi),
  Picking (Arnau) and Shipping/value (Rachel): 60-second version, script,
  data, design, every number with its calculation, risks, Q&A, cheat sheet
- Glossary of plain-language terms added to all four briefings (incl. Gleb's)
- Deck source lines now point to the right report sections: costs D3 §7,
  cost register D3 §9, layout D2 §5, equipment D2 §6.3 and D3 §2.4
- Word converter keeps table columns at least one word wide

Co-Authored-By: Claude Opus 5.5 <noreply@anthropic.com>
Claude-Session: https://claude.ai/code/session_019BDu8Mejto8wmgVTUqspvV
</commit_message>
<xml_diff>
--- a/deliverables/Presentation_Group3_Project_OTM.pptx
+++ b/deliverables/Presentation_Group3_Project_OTM.pptx
@@ -132,24 +132,24 @@
   <p:extLst>
     <p:ext uri="{521415D9-36F7-43E2-AB2F-B90AF26B5E84}">
       <p14:sectionLst xmlns:p14="http://schemas.microsoft.com/office/powerpoint/2010/main">
-        <p14:section name="Summary" id="{4cc1d32b-a088-aae6-ebd6-ba676f973ae5}">
+        <p14:section name="Summary" id="{aef3cf04-592f-5d41-ae1a-3e3efcd9ec28}">
           <p14:sldIdLst>
             <p14:sldId id="256"/>
             <p14:sldId id="257"/>
             <p14:sldId id="258"/>
           </p14:sldIdLst>
         </p14:section>
-        <p14:section name="Today" id="{daad75ba-8684-dcd8-d6e7-159ff325533c}">
+        <p14:section name="Today" id="{558d4f7a-bcf0-8d96-dc68-dab39c1e2006}">
           <p14:sldIdLst>
             <p14:sldId id="259"/>
           </p14:sldIdLst>
         </p14:section>
-        <p14:section name="Our solution" id="{d202ae73-18a2-a332-de3f-b3307d201bb9}">
+        <p14:section name="Our solution" id="{1ea7a1a0-b24a-9c17-d15d-e86348837bcd}">
           <p14:sldIdLst>
             <p14:sldId id="260"/>
           </p14:sldIdLst>
         </p14:section>
-        <p14:section name="Processes" id="{e9459f9e-766b-5d19-bd4a-043d6c000cb7}">
+        <p14:section name="Processes" id="{f784673e-fe6c-019a-c4c7-1973c9789a8b}">
           <p14:sldIdLst>
             <p14:sldId id="261"/>
             <p14:sldId id="262"/>
@@ -157,18 +157,18 @@
             <p14:sldId id="264"/>
           </p14:sldIdLst>
         </p14:section>
-        <p14:section name="Value for DHL" id="{19075c95-e5c1-4521-4ea6-0aef85472a56}">
+        <p14:section name="Value for DHL" id="{d9775d16-b96d-1608-a646-efbf60dd8a9e}">
           <p14:sldIdLst>
             <p14:sldId id="265"/>
           </p14:sldIdLst>
         </p14:section>
-        <p14:section name="Roadmap" id="{246cff86-c73d-5c54-eb9b-bd954b3a8b58}">
+        <p14:section name="Roadmap" id="{97fdeb6b-8860-81f1-d375-e8a57f2770a9}">
           <p14:sldIdLst>
             <p14:sldId id="266"/>
             <p14:sldId id="267"/>
           </p14:sldIdLst>
         </p14:section>
-        <p14:section name="Appendix: calculations" id="{169f7665-f439-0ab3-46de-14c6b655235e}">
+        <p14:section name="Appendix: calculations" id="{1c8484a9-050a-b074-30b6-c3a2530d07c5}">
           <p14:sldIdLst>
             <p14:sldId id="268"/>
             <p14:sldId id="269"/>
@@ -178,7 +178,7 @@
             <p14:sldId id="273"/>
           </p14:sldIdLst>
         </p14:section>
-        <p14:section name="Appendix" id="{878e3075-f9c6-f500-ca01-82aff038fa0d}">
+        <p14:section name="Appendix" id="{cfebe1ab-02ba-7705-1871-6f6aa7566fa9}">
           <p14:sldIdLst>
             <p14:sldId id="274"/>
             <p14:sldId id="275"/>
@@ -6527,7 +6527,7 @@
                   <a:schemeClr val="accent2"/>
                 </a:solidFill>
               </a:rPr>
-              <a:t>Source: cost model (Deliverable 3 §3): racking prices (IndexBox, n.d.; T-Racking, n.d.); labour €20 per hour (Rogier, course teacher, personal communication, October 2026); benchmark prices, not quotes; step by step: appendix "How we calculated: money"</a:t>
+              <a:t>Source: cost model (Deliverable 3 §7): racking prices (IndexBox, n.d.; T-Racking, n.d.); labour €20 per hour (Rogier, course teacher, personal communication, October 2026); benchmark prices, not quotes; step by step: appendix "How we calculated: money"</a:t>
             </a:r>
             <a:endParaRPr lang="en-US" sz="900" dirty="0"/>
           </a:p>
@@ -8627,7 +8627,7 @@
                   <a:schemeClr val="accent2"/>
                 </a:solidFill>
               </a:rPr>
-              <a:t>Source: proposed sequence based on the cost model (Deliverable 3 §3) and the hours saved per change; open points in the appendix</a:t>
+              <a:t>Source: proposed sequence based on the cost model (Deliverable 3 §7) and the hours saved per change; open points in the appendix</a:t>
             </a:r>
             <a:endParaRPr lang="en-US" sz="900" dirty="0"/>
           </a:p>
@@ -9970,7 +9970,7 @@
                   <a:schemeClr val="accent2"/>
                 </a:solidFill>
               </a:rPr>
-              <a:t>Source: stock snapshots 1 April, 1 May, 1 June 2025 (Assa Abloy &amp; DHL Supply Chain, 2025); layout drawing (Deliverable 2 §2); performance_cost.py</a:t>
+              <a:t>Source: stock snapshots 1 April, 1 May, 1 June 2025 (Assa Abloy &amp; DHL Supply Chain, 2025); layout drawing (Deliverable 2 §5); performance_cost.py</a:t>
             </a:r>
             <a:endParaRPr lang="en-US" sz="900" dirty="0"/>
           </a:p>
@@ -16840,7 +16840,7 @@
                   <a:schemeClr val="accent2"/>
                 </a:solidFill>
               </a:rPr>
-              <a:t>Source: cost register (Deliverable 3 §3, data/assumptions.json A030–A046); prices (IndexBox, n.d.; T-Racking, n.d.) and other benchmarks; labour (Rogier, course teacher, personal communication, October 2026); performance_cost.py</a:t>
+              <a:t>Source: cost register (Deliverable 3 §9, data/assumptions.json A030–A046); prices (IndexBox, n.d.; T-Racking, n.d.) and other benchmarks; labour (Rogier, course teacher, personal communication, October 2026); performance_cost.py</a:t>
             </a:r>
             <a:endParaRPr lang="en-US" sz="900" dirty="0"/>
           </a:p>
@@ -18978,7 +18978,7 @@
                   <a:schemeClr val="accent2"/>
                 </a:solidFill>
               </a:rPr>
-              <a:t>Source: capacity plan (Deliverable 2 §6) and cost register (Deliverable 3 §3); lease and price benchmarks (IndexBox, n.d.; T-Racking, n.d.); labour (Rogier, course teacher, personal communication, October 2026); performance_cost.py</a:t>
+              <a:t>Source: capacity plan (Deliverable 2 §6) and cost register (Deliverable 3 §9); lease and price benchmarks (IndexBox, n.d.; T-Racking, n.d.); labour (Rogier, course teacher, personal communication, October 2026); performance_cost.py</a:t>
             </a:r>
             <a:endParaRPr lang="en-US" sz="900" dirty="0"/>
           </a:p>
@@ -32296,7 +32296,7 @@
                   <a:schemeClr val="accent2"/>
                 </a:solidFill>
               </a:rPr>
-              <a:t>Source: cost model (Deliverable 3 §3): racking prices (IndexBox, n.d.; T-Racking, n.d.); labour €20 per hour (Rogier, course teacher, personal communication, October 2026); benchmark prices, not supplier quotes</a:t>
+              <a:t>Source: cost model (Deliverable 3 §7): racking prices (IndexBox, n.d.; T-Racking, n.d.); labour €20 per hour (Rogier, course teacher, personal communication, October 2026); benchmark prices, not supplier quotes</a:t>
             </a:r>
             <a:endParaRPr lang="en-US" sz="900" dirty="0"/>
           </a:p>
@@ -35693,7 +35693,7 @@
                   <a:schemeClr val="accent2"/>
                 </a:solidFill>
               </a:rPr>
-              <a:t>Source: Deliverable 2 §5 and Deliverable 3 stress test; equipment data (Jungheinrich, n.d.-a, n.d.-b, 2019)</a:t>
+              <a:t>Source: Deliverable 2 §6.3 and Deliverable 3 §2.4 (stress test); equipment data (Jungheinrich, n.d.-a, n.d.-b, 2019)</a:t>
             </a:r>
             <a:endParaRPr lang="en-US" sz="900" dirty="0"/>
           </a:p>
@@ -41123,7 +41123,7 @@
                   <a:schemeClr val="accent2"/>
                 </a:solidFill>
               </a:rPr>
-              <a:t>Source: team layout drawing, to scale (Deliverable 2 §2); option choice: team decision matrix (Deliverable 1 §15)</a:t>
+              <a:t>Source: team layout drawing, to scale (Deliverable 2 §5); option choice: team decision matrix (Deliverable 1 §15)</a:t>
             </a:r>
             <a:endParaRPr lang="en-US" sz="900" dirty="0"/>
           </a:p>

</xml_diff>